<commit_message>
Support for user-defined switch/route functions
</commit_message>
<xml_diff>
--- a/docs/pptx-graphics/source-2.pptx
+++ b/docs/pptx-graphics/source-2.pptx
@@ -275,7 +275,7 @@
           <a:p>
             <a:fld id="{2445DC21-F223-6F45-8FE0-96D5E4041F58}" type="datetimeFigureOut">
               <a:rPr lang="en-US" smtClean="0"/>
-              <a:t>3/27/25</a:t>
+              <a:t>5/11/25</a:t>
             </a:fld>
             <a:endParaRPr lang="en-US"/>
           </a:p>
@@ -473,7 +473,7 @@
           <a:p>
             <a:fld id="{2445DC21-F223-6F45-8FE0-96D5E4041F58}" type="datetimeFigureOut">
               <a:rPr lang="en-US" smtClean="0"/>
-              <a:t>3/27/25</a:t>
+              <a:t>5/11/25</a:t>
             </a:fld>
             <a:endParaRPr lang="en-US"/>
           </a:p>
@@ -681,7 +681,7 @@
           <a:p>
             <a:fld id="{2445DC21-F223-6F45-8FE0-96D5E4041F58}" type="datetimeFigureOut">
               <a:rPr lang="en-US" smtClean="0"/>
-              <a:t>3/27/25</a:t>
+              <a:t>5/11/25</a:t>
             </a:fld>
             <a:endParaRPr lang="en-US"/>
           </a:p>
@@ -879,7 +879,7 @@
           <a:p>
             <a:fld id="{2445DC21-F223-6F45-8FE0-96D5E4041F58}" type="datetimeFigureOut">
               <a:rPr lang="en-US" smtClean="0"/>
-              <a:t>3/27/25</a:t>
+              <a:t>5/11/25</a:t>
             </a:fld>
             <a:endParaRPr lang="en-US"/>
           </a:p>
@@ -1154,7 +1154,7 @@
           <a:p>
             <a:fld id="{2445DC21-F223-6F45-8FE0-96D5E4041F58}" type="datetimeFigureOut">
               <a:rPr lang="en-US" smtClean="0"/>
-              <a:t>3/27/25</a:t>
+              <a:t>5/11/25</a:t>
             </a:fld>
             <a:endParaRPr lang="en-US"/>
           </a:p>
@@ -1419,7 +1419,7 @@
           <a:p>
             <a:fld id="{2445DC21-F223-6F45-8FE0-96D5E4041F58}" type="datetimeFigureOut">
               <a:rPr lang="en-US" smtClean="0"/>
-              <a:t>3/27/25</a:t>
+              <a:t>5/11/25</a:t>
             </a:fld>
             <a:endParaRPr lang="en-US"/>
           </a:p>
@@ -1831,7 +1831,7 @@
           <a:p>
             <a:fld id="{2445DC21-F223-6F45-8FE0-96D5E4041F58}" type="datetimeFigureOut">
               <a:rPr lang="en-US" smtClean="0"/>
-              <a:t>3/27/25</a:t>
+              <a:t>5/11/25</a:t>
             </a:fld>
             <a:endParaRPr lang="en-US"/>
           </a:p>
@@ -1972,7 +1972,7 @@
           <a:p>
             <a:fld id="{2445DC21-F223-6F45-8FE0-96D5E4041F58}" type="datetimeFigureOut">
               <a:rPr lang="en-US" smtClean="0"/>
-              <a:t>3/27/25</a:t>
+              <a:t>5/11/25</a:t>
             </a:fld>
             <a:endParaRPr lang="en-US"/>
           </a:p>
@@ -2085,7 +2085,7 @@
           <a:p>
             <a:fld id="{2445DC21-F223-6F45-8FE0-96D5E4041F58}" type="datetimeFigureOut">
               <a:rPr lang="en-US" smtClean="0"/>
-              <a:t>3/27/25</a:t>
+              <a:t>5/11/25</a:t>
             </a:fld>
             <a:endParaRPr lang="en-US"/>
           </a:p>
@@ -2396,7 +2396,7 @@
           <a:p>
             <a:fld id="{2445DC21-F223-6F45-8FE0-96D5E4041F58}" type="datetimeFigureOut">
               <a:rPr lang="en-US" smtClean="0"/>
-              <a:t>3/27/25</a:t>
+              <a:t>5/11/25</a:t>
             </a:fld>
             <a:endParaRPr lang="en-US"/>
           </a:p>
@@ -2684,7 +2684,7 @@
           <a:p>
             <a:fld id="{2445DC21-F223-6F45-8FE0-96D5E4041F58}" type="datetimeFigureOut">
               <a:rPr lang="en-US" smtClean="0"/>
-              <a:t>3/27/25</a:t>
+              <a:t>5/11/25</a:t>
             </a:fld>
             <a:endParaRPr lang="en-US"/>
           </a:p>
@@ -2925,7 +2925,7 @@
           <a:p>
             <a:fld id="{2445DC21-F223-6F45-8FE0-96D5E4041F58}" type="datetimeFigureOut">
               <a:rPr lang="en-US" smtClean="0"/>
-              <a:t>3/27/25</a:t>
+              <a:t>5/11/25</a:t>
             </a:fld>
             <a:endParaRPr lang="en-US"/>
           </a:p>
@@ -28703,7 +28703,7 @@
         <p:spPr>
           <a:xfrm>
             <a:off x="4036464" y="1366624"/>
-            <a:ext cx="879664" cy="307777"/>
+            <a:ext cx="825291" cy="307777"/>
           </a:xfrm>
           <a:prstGeom prst="rect">
             <a:avLst/>
@@ -28718,7 +28718,7 @@
           <a:p>
             <a:r>
               <a:rPr lang="en-US" sz="1400" dirty="0"/>
-              <a:t>hubWest</a:t>
+              <a:t>hubEast</a:t>
             </a:r>
           </a:p>
         </p:txBody>

</xml_diff>

<commit_message>
integrated with modifications for inserting pcap feeds
</commit_message>
<xml_diff>
--- a/docs/pptx-graphics/source-2.pptx
+++ b/docs/pptx-graphics/source-2.pptx
@@ -22,6 +22,7 @@
     <p:sldId id="269" r:id="rId16"/>
     <p:sldId id="270" r:id="rId17"/>
     <p:sldId id="272" r:id="rId18"/>
+    <p:sldId id="273" r:id="rId19"/>
   </p:sldIdLst>
   <p:sldSz cx="12192000" cy="6858000"/>
   <p:notesSz cx="6858000" cy="9144000"/>
@@ -275,7 +276,7 @@
           <a:p>
             <a:fld id="{2445DC21-F223-6F45-8FE0-96D5E4041F58}" type="datetimeFigureOut">
               <a:rPr lang="en-US" smtClean="0"/>
-              <a:t>5/11/25</a:t>
+              <a:t>5/21/25</a:t>
             </a:fld>
             <a:endParaRPr lang="en-US"/>
           </a:p>
@@ -473,7 +474,7 @@
           <a:p>
             <a:fld id="{2445DC21-F223-6F45-8FE0-96D5E4041F58}" type="datetimeFigureOut">
               <a:rPr lang="en-US" smtClean="0"/>
-              <a:t>5/11/25</a:t>
+              <a:t>5/21/25</a:t>
             </a:fld>
             <a:endParaRPr lang="en-US"/>
           </a:p>
@@ -681,7 +682,7 @@
           <a:p>
             <a:fld id="{2445DC21-F223-6F45-8FE0-96D5E4041F58}" type="datetimeFigureOut">
               <a:rPr lang="en-US" smtClean="0"/>
-              <a:t>5/11/25</a:t>
+              <a:t>5/21/25</a:t>
             </a:fld>
             <a:endParaRPr lang="en-US"/>
           </a:p>
@@ -879,7 +880,7 @@
           <a:p>
             <a:fld id="{2445DC21-F223-6F45-8FE0-96D5E4041F58}" type="datetimeFigureOut">
               <a:rPr lang="en-US" smtClean="0"/>
-              <a:t>5/11/25</a:t>
+              <a:t>5/21/25</a:t>
             </a:fld>
             <a:endParaRPr lang="en-US"/>
           </a:p>
@@ -1154,7 +1155,7 @@
           <a:p>
             <a:fld id="{2445DC21-F223-6F45-8FE0-96D5E4041F58}" type="datetimeFigureOut">
               <a:rPr lang="en-US" smtClean="0"/>
-              <a:t>5/11/25</a:t>
+              <a:t>5/21/25</a:t>
             </a:fld>
             <a:endParaRPr lang="en-US"/>
           </a:p>
@@ -1419,7 +1420,7 @@
           <a:p>
             <a:fld id="{2445DC21-F223-6F45-8FE0-96D5E4041F58}" type="datetimeFigureOut">
               <a:rPr lang="en-US" smtClean="0"/>
-              <a:t>5/11/25</a:t>
+              <a:t>5/21/25</a:t>
             </a:fld>
             <a:endParaRPr lang="en-US"/>
           </a:p>
@@ -1831,7 +1832,7 @@
           <a:p>
             <a:fld id="{2445DC21-F223-6F45-8FE0-96D5E4041F58}" type="datetimeFigureOut">
               <a:rPr lang="en-US" smtClean="0"/>
-              <a:t>5/11/25</a:t>
+              <a:t>5/21/25</a:t>
             </a:fld>
             <a:endParaRPr lang="en-US"/>
           </a:p>
@@ -1972,7 +1973,7 @@
           <a:p>
             <a:fld id="{2445DC21-F223-6F45-8FE0-96D5E4041F58}" type="datetimeFigureOut">
               <a:rPr lang="en-US" smtClean="0"/>
-              <a:t>5/11/25</a:t>
+              <a:t>5/21/25</a:t>
             </a:fld>
             <a:endParaRPr lang="en-US"/>
           </a:p>
@@ -2085,7 +2086,7 @@
           <a:p>
             <a:fld id="{2445DC21-F223-6F45-8FE0-96D5E4041F58}" type="datetimeFigureOut">
               <a:rPr lang="en-US" smtClean="0"/>
-              <a:t>5/11/25</a:t>
+              <a:t>5/21/25</a:t>
             </a:fld>
             <a:endParaRPr lang="en-US"/>
           </a:p>
@@ -2396,7 +2397,7 @@
           <a:p>
             <a:fld id="{2445DC21-F223-6F45-8FE0-96D5E4041F58}" type="datetimeFigureOut">
               <a:rPr lang="en-US" smtClean="0"/>
-              <a:t>5/11/25</a:t>
+              <a:t>5/21/25</a:t>
             </a:fld>
             <a:endParaRPr lang="en-US"/>
           </a:p>
@@ -2684,7 +2685,7 @@
           <a:p>
             <a:fld id="{2445DC21-F223-6F45-8FE0-96D5E4041F58}" type="datetimeFigureOut">
               <a:rPr lang="en-US" smtClean="0"/>
-              <a:t>5/11/25</a:t>
+              <a:t>5/21/25</a:t>
             </a:fld>
             <a:endParaRPr lang="en-US"/>
           </a:p>
@@ -2925,7 +2926,7 @@
           <a:p>
             <a:fld id="{2445DC21-F223-6F45-8FE0-96D5E4041F58}" type="datetimeFigureOut">
               <a:rPr lang="en-US" smtClean="0"/>
-              <a:t>5/11/25</a:t>
+              <a:t>5/21/25</a:t>
             </a:fld>
             <a:endParaRPr lang="en-US"/>
           </a:p>
@@ -30195,6 +30196,1847 @@
 </p:sld>
 </file>
 
+<file path=ppt/slides/slide18.xml><?xml version="1.0" encoding="utf-8"?>
+<p:sld xmlns:a="http://schemas.openxmlformats.org/drawingml/2006/main" xmlns:r="http://schemas.openxmlformats.org/officeDocument/2006/relationships" xmlns:p="http://schemas.openxmlformats.org/presentationml/2006/main">
+  <p:cSld>
+    <p:spTree>
+      <p:nvGrpSpPr>
+        <p:cNvPr id="1" name="">
+          <a:extLst>
+            <a:ext uri="{FF2B5EF4-FFF2-40B4-BE49-F238E27FC236}">
+              <a16:creationId xmlns:a16="http://schemas.microsoft.com/office/drawing/2014/main" id="{5FEBCA85-4D16-513D-E409-A72A30D59026}"/>
+            </a:ext>
+          </a:extLst>
+        </p:cNvPr>
+        <p:cNvGrpSpPr/>
+        <p:nvPr/>
+      </p:nvGrpSpPr>
+      <p:grpSpPr>
+        <a:xfrm>
+          <a:off x="0" y="0"/>
+          <a:ext cx="0" cy="0"/>
+          <a:chOff x="0" y="0"/>
+          <a:chExt cx="0" cy="0"/>
+        </a:xfrm>
+      </p:grpSpPr>
+      <p:sp>
+        <p:nvSpPr>
+          <p:cNvPr id="11" name="Rectangle 10">
+            <a:extLst>
+              <a:ext uri="{FF2B5EF4-FFF2-40B4-BE49-F238E27FC236}">
+                <a16:creationId xmlns:a16="http://schemas.microsoft.com/office/drawing/2014/main" id="{BE424E3B-E20A-EF4C-2A4B-50BC0557FA26}"/>
+              </a:ext>
+            </a:extLst>
+          </p:cNvPr>
+          <p:cNvSpPr/>
+          <p:nvPr/>
+        </p:nvSpPr>
+        <p:spPr>
+          <a:xfrm>
+            <a:off x="1166321" y="1079031"/>
+            <a:ext cx="737528" cy="376594"/>
+          </a:xfrm>
+          <a:prstGeom prst="rect">
+            <a:avLst/>
+          </a:prstGeom>
+          <a:solidFill>
+            <a:schemeClr val="accent2">
+              <a:lumMod val="20000"/>
+              <a:lumOff val="80000"/>
+            </a:schemeClr>
+          </a:solidFill>
+        </p:spPr>
+        <p:style>
+          <a:lnRef idx="2">
+            <a:schemeClr val="accent1">
+              <a:shade val="15000"/>
+            </a:schemeClr>
+          </a:lnRef>
+          <a:fillRef idx="1">
+            <a:schemeClr val="accent1"/>
+          </a:fillRef>
+          <a:effectRef idx="0">
+            <a:schemeClr val="accent1"/>
+          </a:effectRef>
+          <a:fontRef idx="minor">
+            <a:schemeClr val="lt1"/>
+          </a:fontRef>
+        </p:style>
+        <p:txBody>
+          <a:bodyPr rtlCol="0" anchor="ctr"/>
+          <a:lstStyle/>
+          <a:p>
+            <a:pPr algn="ctr"/>
+            <a:endParaRPr lang="en-US"/>
+          </a:p>
+        </p:txBody>
+      </p:sp>
+      <p:sp>
+        <p:nvSpPr>
+          <p:cNvPr id="12" name="TextBox 11">
+            <a:extLst>
+              <a:ext uri="{FF2B5EF4-FFF2-40B4-BE49-F238E27FC236}">
+                <a16:creationId xmlns:a16="http://schemas.microsoft.com/office/drawing/2014/main" id="{4A06B252-1CBD-4BA5-0E0E-FAEDF30ABFD5}"/>
+              </a:ext>
+            </a:extLst>
+          </p:cNvPr>
+          <p:cNvSpPr txBox="1"/>
+          <p:nvPr/>
+        </p:nvSpPr>
+        <p:spPr>
+          <a:xfrm>
+            <a:off x="1126453" y="1112709"/>
+            <a:ext cx="765722" cy="307777"/>
+          </a:xfrm>
+          <a:prstGeom prst="rect">
+            <a:avLst/>
+          </a:prstGeom>
+          <a:noFill/>
+        </p:spPr>
+        <p:txBody>
+          <a:bodyPr wrap="none" rtlCol="0">
+            <a:spAutoFit/>
+          </a:bodyPr>
+          <a:lstStyle/>
+          <a:p>
+            <a:r>
+              <a:rPr lang="en-US" sz="1400" dirty="0"/>
+              <a:t>WE_src</a:t>
+            </a:r>
+          </a:p>
+        </p:txBody>
+      </p:sp>
+      <p:sp>
+        <p:nvSpPr>
+          <p:cNvPr id="13" name="Rectangle 12">
+            <a:extLst>
+              <a:ext uri="{FF2B5EF4-FFF2-40B4-BE49-F238E27FC236}">
+                <a16:creationId xmlns:a16="http://schemas.microsoft.com/office/drawing/2014/main" id="{7E08EFED-9569-48D0-DD79-58A568464A37}"/>
+              </a:ext>
+            </a:extLst>
+          </p:cNvPr>
+          <p:cNvSpPr/>
+          <p:nvPr/>
+        </p:nvSpPr>
+        <p:spPr>
+          <a:xfrm>
+            <a:off x="2062340" y="925127"/>
+            <a:ext cx="823242" cy="694906"/>
+          </a:xfrm>
+          <a:prstGeom prst="rect">
+            <a:avLst/>
+          </a:prstGeom>
+          <a:solidFill>
+            <a:schemeClr val="accent4">
+              <a:lumMod val="20000"/>
+              <a:lumOff val="80000"/>
+            </a:schemeClr>
+          </a:solidFill>
+        </p:spPr>
+        <p:style>
+          <a:lnRef idx="2">
+            <a:schemeClr val="accent1">
+              <a:shade val="15000"/>
+            </a:schemeClr>
+          </a:lnRef>
+          <a:fillRef idx="1">
+            <a:schemeClr val="accent1"/>
+          </a:fillRef>
+          <a:effectRef idx="0">
+            <a:schemeClr val="accent1"/>
+          </a:effectRef>
+          <a:fontRef idx="minor">
+            <a:schemeClr val="lt1"/>
+          </a:fontRef>
+        </p:style>
+        <p:txBody>
+          <a:bodyPr rtlCol="0" anchor="ctr"/>
+          <a:lstStyle/>
+          <a:p>
+            <a:pPr algn="ctr"/>
+            <a:endParaRPr lang="en-US"/>
+          </a:p>
+        </p:txBody>
+      </p:sp>
+      <p:sp>
+        <p:nvSpPr>
+          <p:cNvPr id="14" name="TextBox 13">
+            <a:extLst>
+              <a:ext uri="{FF2B5EF4-FFF2-40B4-BE49-F238E27FC236}">
+                <a16:creationId xmlns:a16="http://schemas.microsoft.com/office/drawing/2014/main" id="{2E292A1C-999A-2D18-0CA6-4963DA938E64}"/>
+              </a:ext>
+            </a:extLst>
+          </p:cNvPr>
+          <p:cNvSpPr txBox="1"/>
+          <p:nvPr/>
+        </p:nvSpPr>
+        <p:spPr>
+          <a:xfrm>
+            <a:off x="2199994" y="632086"/>
+            <a:ext cx="524503" cy="1015663"/>
+          </a:xfrm>
+          <a:prstGeom prst="rect">
+            <a:avLst/>
+          </a:prstGeom>
+          <a:noFill/>
+        </p:spPr>
+        <p:txBody>
+          <a:bodyPr wrap="none" rtlCol="0">
+            <a:spAutoFit/>
+          </a:bodyPr>
+          <a:lstStyle/>
+          <a:p>
+            <a:r>
+              <a:rPr lang="en-US" sz="6000" dirty="0"/>
+              <a:t>x</a:t>
+            </a:r>
+          </a:p>
+        </p:txBody>
+      </p:sp>
+      <p:sp>
+        <p:nvSpPr>
+          <p:cNvPr id="15" name="TextBox 14">
+            <a:extLst>
+              <a:ext uri="{FF2B5EF4-FFF2-40B4-BE49-F238E27FC236}">
+                <a16:creationId xmlns:a16="http://schemas.microsoft.com/office/drawing/2014/main" id="{444482DB-530E-29A6-FDFC-BE48569341B9}"/>
+              </a:ext>
+            </a:extLst>
+          </p:cNvPr>
+          <p:cNvSpPr txBox="1"/>
+          <p:nvPr/>
+        </p:nvSpPr>
+        <p:spPr>
+          <a:xfrm>
+            <a:off x="2046775" y="1339972"/>
+            <a:ext cx="879664" cy="307777"/>
+          </a:xfrm>
+          <a:prstGeom prst="rect">
+            <a:avLst/>
+          </a:prstGeom>
+          <a:noFill/>
+        </p:spPr>
+        <p:txBody>
+          <a:bodyPr wrap="none" rtlCol="0">
+            <a:spAutoFit/>
+          </a:bodyPr>
+          <a:lstStyle/>
+          <a:p>
+            <a:r>
+              <a:rPr lang="en-US" sz="1400" dirty="0"/>
+              <a:t>hubWest</a:t>
+            </a:r>
+          </a:p>
+        </p:txBody>
+      </p:sp>
+      <p:grpSp>
+        <p:nvGrpSpPr>
+          <p:cNvPr id="16" name="Group 15">
+            <a:extLst>
+              <a:ext uri="{FF2B5EF4-FFF2-40B4-BE49-F238E27FC236}">
+                <a16:creationId xmlns:a16="http://schemas.microsoft.com/office/drawing/2014/main" id="{29699022-7927-FE2B-E351-AA66446D3B6F}"/>
+              </a:ext>
+            </a:extLst>
+          </p:cNvPr>
+          <p:cNvGrpSpPr/>
+          <p:nvPr/>
+        </p:nvGrpSpPr>
+        <p:grpSpPr>
+          <a:xfrm>
+            <a:off x="3123812" y="940606"/>
+            <a:ext cx="644638" cy="644638"/>
+            <a:chOff x="8987933" y="1277123"/>
+            <a:chExt cx="644638" cy="644638"/>
+          </a:xfrm>
+        </p:grpSpPr>
+        <p:sp>
+          <p:nvSpPr>
+            <p:cNvPr id="55" name="Oval 54">
+              <a:extLst>
+                <a:ext uri="{FF2B5EF4-FFF2-40B4-BE49-F238E27FC236}">
+                  <a16:creationId xmlns:a16="http://schemas.microsoft.com/office/drawing/2014/main" id="{5AAC8B57-1F9C-8BC5-F4E9-E6515B55023B}"/>
+                </a:ext>
+              </a:extLst>
+            </p:cNvPr>
+            <p:cNvSpPr/>
+            <p:nvPr/>
+          </p:nvSpPr>
+          <p:spPr>
+            <a:xfrm>
+              <a:off x="8987933" y="1277123"/>
+              <a:ext cx="644638" cy="644638"/>
+            </a:xfrm>
+            <a:prstGeom prst="ellipse">
+              <a:avLst/>
+            </a:prstGeom>
+            <a:solidFill>
+              <a:schemeClr val="tx2">
+                <a:lumMod val="25000"/>
+                <a:lumOff val="75000"/>
+              </a:schemeClr>
+            </a:solidFill>
+          </p:spPr>
+          <p:style>
+            <a:lnRef idx="2">
+              <a:schemeClr val="accent1">
+                <a:shade val="15000"/>
+              </a:schemeClr>
+            </a:lnRef>
+            <a:fillRef idx="1">
+              <a:schemeClr val="accent1"/>
+            </a:fillRef>
+            <a:effectRef idx="0">
+              <a:schemeClr val="accent1"/>
+            </a:effectRef>
+            <a:fontRef idx="minor">
+              <a:schemeClr val="lt1"/>
+            </a:fontRef>
+          </p:style>
+          <p:txBody>
+            <a:bodyPr rtlCol="0" anchor="ctr"/>
+            <a:lstStyle/>
+            <a:p>
+              <a:pPr algn="ctr"/>
+              <a:endParaRPr lang="en-US"/>
+            </a:p>
+          </p:txBody>
+        </p:sp>
+        <p:grpSp>
+          <p:nvGrpSpPr>
+            <p:cNvPr id="56" name="Group 55">
+              <a:extLst>
+                <a:ext uri="{FF2B5EF4-FFF2-40B4-BE49-F238E27FC236}">
+                  <a16:creationId xmlns:a16="http://schemas.microsoft.com/office/drawing/2014/main" id="{64844445-4647-A4DD-E429-02AF9A5FC18B}"/>
+                </a:ext>
+              </a:extLst>
+            </p:cNvPr>
+            <p:cNvGrpSpPr/>
+            <p:nvPr/>
+          </p:nvGrpSpPr>
+          <p:grpSpPr>
+            <a:xfrm>
+              <a:off x="9056714" y="1328837"/>
+              <a:ext cx="523702" cy="543097"/>
+              <a:chOff x="9044247" y="1323964"/>
+              <a:chExt cx="523702" cy="543097"/>
+            </a:xfrm>
+          </p:grpSpPr>
+          <p:cxnSp>
+            <p:nvCxnSpPr>
+              <p:cNvPr id="57" name="Straight Arrow Connector 56">
+                <a:extLst>
+                  <a:ext uri="{FF2B5EF4-FFF2-40B4-BE49-F238E27FC236}">
+                    <a16:creationId xmlns:a16="http://schemas.microsoft.com/office/drawing/2014/main" id="{45A27CDB-2814-EAAC-3819-409D2A143523}"/>
+                  </a:ext>
+                </a:extLst>
+              </p:cNvPr>
+              <p:cNvCxnSpPr/>
+              <p:nvPr/>
+            </p:nvCxnSpPr>
+            <p:spPr>
+              <a:xfrm>
+                <a:off x="9044247" y="1599442"/>
+                <a:ext cx="232757" cy="0"/>
+              </a:xfrm>
+              <a:prstGeom prst="straightConnector1">
+                <a:avLst/>
+              </a:prstGeom>
+              <a:ln w="34925">
+                <a:tailEnd type="triangle"/>
+              </a:ln>
+            </p:spPr>
+            <p:style>
+              <a:lnRef idx="2">
+                <a:schemeClr val="accent1"/>
+              </a:lnRef>
+              <a:fillRef idx="0">
+                <a:schemeClr val="accent1"/>
+              </a:fillRef>
+              <a:effectRef idx="1">
+                <a:schemeClr val="accent1"/>
+              </a:effectRef>
+              <a:fontRef idx="minor">
+                <a:schemeClr val="tx1"/>
+              </a:fontRef>
+            </p:style>
+          </p:cxnSp>
+          <p:cxnSp>
+            <p:nvCxnSpPr>
+              <p:cNvPr id="58" name="Straight Arrow Connector 57">
+                <a:extLst>
+                  <a:ext uri="{FF2B5EF4-FFF2-40B4-BE49-F238E27FC236}">
+                    <a16:creationId xmlns:a16="http://schemas.microsoft.com/office/drawing/2014/main" id="{C21B9290-F677-92EA-7042-E3D4A59195E5}"/>
+                  </a:ext>
+                </a:extLst>
+              </p:cNvPr>
+              <p:cNvCxnSpPr>
+                <a:cxnSpLocks/>
+              </p:cNvCxnSpPr>
+              <p:nvPr/>
+            </p:nvCxnSpPr>
+            <p:spPr>
+              <a:xfrm flipH="1">
+                <a:off x="9335192" y="1598242"/>
+                <a:ext cx="232757" cy="0"/>
+              </a:xfrm>
+              <a:prstGeom prst="straightConnector1">
+                <a:avLst/>
+              </a:prstGeom>
+              <a:ln w="34925">
+                <a:tailEnd type="triangle"/>
+              </a:ln>
+            </p:spPr>
+            <p:style>
+              <a:lnRef idx="2">
+                <a:schemeClr val="accent1"/>
+              </a:lnRef>
+              <a:fillRef idx="0">
+                <a:schemeClr val="accent1"/>
+              </a:fillRef>
+              <a:effectRef idx="1">
+                <a:schemeClr val="accent1"/>
+              </a:effectRef>
+              <a:fontRef idx="minor">
+                <a:schemeClr val="tx1"/>
+              </a:fontRef>
+            </p:style>
+          </p:cxnSp>
+          <p:cxnSp>
+            <p:nvCxnSpPr>
+              <p:cNvPr id="59" name="Straight Arrow Connector 58">
+                <a:extLst>
+                  <a:ext uri="{FF2B5EF4-FFF2-40B4-BE49-F238E27FC236}">
+                    <a16:creationId xmlns:a16="http://schemas.microsoft.com/office/drawing/2014/main" id="{1240F6BC-CF6E-9C49-09BB-DE228B7F8EE5}"/>
+                  </a:ext>
+                </a:extLst>
+              </p:cNvPr>
+              <p:cNvCxnSpPr>
+                <a:cxnSpLocks/>
+              </p:cNvCxnSpPr>
+              <p:nvPr/>
+            </p:nvCxnSpPr>
+            <p:spPr>
+              <a:xfrm rot="16200000" flipV="1">
+                <a:off x="9193874" y="1440343"/>
+                <a:ext cx="232757" cy="0"/>
+              </a:xfrm>
+              <a:prstGeom prst="straightConnector1">
+                <a:avLst/>
+              </a:prstGeom>
+              <a:ln w="34925">
+                <a:tailEnd type="triangle"/>
+              </a:ln>
+            </p:spPr>
+            <p:style>
+              <a:lnRef idx="2">
+                <a:schemeClr val="accent1"/>
+              </a:lnRef>
+              <a:fillRef idx="0">
+                <a:schemeClr val="accent1"/>
+              </a:fillRef>
+              <a:effectRef idx="1">
+                <a:schemeClr val="accent1"/>
+              </a:effectRef>
+              <a:fontRef idx="minor">
+                <a:schemeClr val="tx1"/>
+              </a:fontRef>
+            </p:style>
+          </p:cxnSp>
+          <p:cxnSp>
+            <p:nvCxnSpPr>
+              <p:cNvPr id="60" name="Straight Arrow Connector 59">
+                <a:extLst>
+                  <a:ext uri="{FF2B5EF4-FFF2-40B4-BE49-F238E27FC236}">
+                    <a16:creationId xmlns:a16="http://schemas.microsoft.com/office/drawing/2014/main" id="{DFD41C6E-3B83-C02B-5FC7-E899F324E759}"/>
+                  </a:ext>
+                </a:extLst>
+              </p:cNvPr>
+              <p:cNvCxnSpPr>
+                <a:cxnSpLocks/>
+              </p:cNvCxnSpPr>
+              <p:nvPr/>
+            </p:nvCxnSpPr>
+            <p:spPr>
+              <a:xfrm rot="5400000">
+                <a:off x="9196646" y="1750683"/>
+                <a:ext cx="232757" cy="0"/>
+              </a:xfrm>
+              <a:prstGeom prst="straightConnector1">
+                <a:avLst/>
+              </a:prstGeom>
+              <a:ln w="34925">
+                <a:tailEnd type="triangle"/>
+              </a:ln>
+            </p:spPr>
+            <p:style>
+              <a:lnRef idx="2">
+                <a:schemeClr val="accent1"/>
+              </a:lnRef>
+              <a:fillRef idx="0">
+                <a:schemeClr val="accent1"/>
+              </a:fillRef>
+              <a:effectRef idx="1">
+                <a:schemeClr val="accent1"/>
+              </a:effectRef>
+              <a:fontRef idx="minor">
+                <a:schemeClr val="tx1"/>
+              </a:fontRef>
+            </p:style>
+          </p:cxnSp>
+        </p:grpSp>
+      </p:grpSp>
+      <p:sp>
+        <p:nvSpPr>
+          <p:cNvPr id="17" name="TextBox 16">
+            <a:extLst>
+              <a:ext uri="{FF2B5EF4-FFF2-40B4-BE49-F238E27FC236}">
+                <a16:creationId xmlns:a16="http://schemas.microsoft.com/office/drawing/2014/main" id="{0312AD4A-2EB8-3EBE-DCF3-E830BC318FC1}"/>
+              </a:ext>
+            </a:extLst>
+          </p:cNvPr>
+          <p:cNvSpPr txBox="1"/>
+          <p:nvPr/>
+        </p:nvSpPr>
+        <p:spPr>
+          <a:xfrm>
+            <a:off x="2996126" y="704461"/>
+            <a:ext cx="360996" cy="307777"/>
+          </a:xfrm>
+          <a:prstGeom prst="rect">
+            <a:avLst/>
+          </a:prstGeom>
+          <a:noFill/>
+        </p:spPr>
+        <p:txBody>
+          <a:bodyPr wrap="none" rtlCol="0">
+            <a:spAutoFit/>
+          </a:bodyPr>
+          <a:lstStyle/>
+          <a:p>
+            <a:r>
+              <a:rPr lang="en-US" sz="1400" dirty="0"/>
+              <a:t>rtr</a:t>
+            </a:r>
+          </a:p>
+        </p:txBody>
+      </p:sp>
+      <p:cxnSp>
+        <p:nvCxnSpPr>
+          <p:cNvPr id="35" name="Straight Connector 34">
+            <a:extLst>
+              <a:ext uri="{FF2B5EF4-FFF2-40B4-BE49-F238E27FC236}">
+                <a16:creationId xmlns:a16="http://schemas.microsoft.com/office/drawing/2014/main" id="{45EF0E52-8084-F886-4017-1EEBE8EF8B55}"/>
+              </a:ext>
+            </a:extLst>
+          </p:cNvPr>
+          <p:cNvCxnSpPr>
+            <a:cxnSpLocks/>
+          </p:cNvCxnSpPr>
+          <p:nvPr/>
+        </p:nvCxnSpPr>
+        <p:spPr>
+          <a:xfrm>
+            <a:off x="3785210" y="1299159"/>
+            <a:ext cx="273964" cy="1006"/>
+          </a:xfrm>
+          <a:prstGeom prst="line">
+            <a:avLst/>
+          </a:prstGeom>
+        </p:spPr>
+        <p:style>
+          <a:lnRef idx="2">
+            <a:schemeClr val="accent1"/>
+          </a:lnRef>
+          <a:fillRef idx="0">
+            <a:schemeClr val="accent1"/>
+          </a:fillRef>
+          <a:effectRef idx="1">
+            <a:schemeClr val="accent1"/>
+          </a:effectRef>
+          <a:fontRef idx="minor">
+            <a:schemeClr val="tx1"/>
+          </a:fontRef>
+        </p:style>
+      </p:cxnSp>
+      <p:cxnSp>
+        <p:nvCxnSpPr>
+          <p:cNvPr id="36" name="Straight Connector 35">
+            <a:extLst>
+              <a:ext uri="{FF2B5EF4-FFF2-40B4-BE49-F238E27FC236}">
+                <a16:creationId xmlns:a16="http://schemas.microsoft.com/office/drawing/2014/main" id="{F1911DE0-B3F3-EE0A-8033-7997D995BC98}"/>
+              </a:ext>
+            </a:extLst>
+          </p:cNvPr>
+          <p:cNvCxnSpPr>
+            <a:cxnSpLocks/>
+          </p:cNvCxnSpPr>
+          <p:nvPr/>
+        </p:nvCxnSpPr>
+        <p:spPr>
+          <a:xfrm flipH="1">
+            <a:off x="2879689" y="1266597"/>
+            <a:ext cx="238350" cy="0"/>
+          </a:xfrm>
+          <a:prstGeom prst="line">
+            <a:avLst/>
+          </a:prstGeom>
+        </p:spPr>
+        <p:style>
+          <a:lnRef idx="2">
+            <a:schemeClr val="accent1"/>
+          </a:lnRef>
+          <a:fillRef idx="0">
+            <a:schemeClr val="accent1"/>
+          </a:fillRef>
+          <a:effectRef idx="1">
+            <a:schemeClr val="accent1"/>
+          </a:effectRef>
+          <a:fontRef idx="minor">
+            <a:schemeClr val="tx1"/>
+          </a:fontRef>
+        </p:style>
+      </p:cxnSp>
+      <p:cxnSp>
+        <p:nvCxnSpPr>
+          <p:cNvPr id="37" name="Straight Connector 36">
+            <a:extLst>
+              <a:ext uri="{FF2B5EF4-FFF2-40B4-BE49-F238E27FC236}">
+                <a16:creationId xmlns:a16="http://schemas.microsoft.com/office/drawing/2014/main" id="{5181BE12-C036-4391-1991-EBFBE7AA8942}"/>
+              </a:ext>
+            </a:extLst>
+          </p:cNvPr>
+          <p:cNvCxnSpPr>
+            <a:cxnSpLocks/>
+          </p:cNvCxnSpPr>
+          <p:nvPr/>
+        </p:nvCxnSpPr>
+        <p:spPr>
+          <a:xfrm flipH="1">
+            <a:off x="1919260" y="1272580"/>
+            <a:ext cx="127515" cy="0"/>
+          </a:xfrm>
+          <a:prstGeom prst="line">
+            <a:avLst/>
+          </a:prstGeom>
+        </p:spPr>
+        <p:style>
+          <a:lnRef idx="2">
+            <a:schemeClr val="accent1"/>
+          </a:lnRef>
+          <a:fillRef idx="0">
+            <a:schemeClr val="accent1"/>
+          </a:fillRef>
+          <a:effectRef idx="1">
+            <a:schemeClr val="accent1"/>
+          </a:effectRef>
+          <a:fontRef idx="minor">
+            <a:schemeClr val="tx1"/>
+          </a:fontRef>
+        </p:style>
+      </p:cxnSp>
+      <p:sp>
+        <p:nvSpPr>
+          <p:cNvPr id="63" name="Rectangle 62">
+            <a:extLst>
+              <a:ext uri="{FF2B5EF4-FFF2-40B4-BE49-F238E27FC236}">
+                <a16:creationId xmlns:a16="http://schemas.microsoft.com/office/drawing/2014/main" id="{B222CA0B-BEDC-505C-C6DE-4D4629C591EA}"/>
+              </a:ext>
+            </a:extLst>
+          </p:cNvPr>
+          <p:cNvSpPr/>
+          <p:nvPr/>
+        </p:nvSpPr>
+        <p:spPr>
+          <a:xfrm>
+            <a:off x="2103202" y="1761318"/>
+            <a:ext cx="737528" cy="376594"/>
+          </a:xfrm>
+          <a:prstGeom prst="rect">
+            <a:avLst/>
+          </a:prstGeom>
+          <a:solidFill>
+            <a:schemeClr val="accent2">
+              <a:lumMod val="20000"/>
+              <a:lumOff val="80000"/>
+            </a:schemeClr>
+          </a:solidFill>
+        </p:spPr>
+        <p:style>
+          <a:lnRef idx="2">
+            <a:schemeClr val="accent1">
+              <a:shade val="15000"/>
+            </a:schemeClr>
+          </a:lnRef>
+          <a:fillRef idx="1">
+            <a:schemeClr val="accent1"/>
+          </a:fillRef>
+          <a:effectRef idx="0">
+            <a:schemeClr val="accent1"/>
+          </a:effectRef>
+          <a:fontRef idx="minor">
+            <a:schemeClr val="lt1"/>
+          </a:fontRef>
+        </p:style>
+        <p:txBody>
+          <a:bodyPr rtlCol="0" anchor="ctr"/>
+          <a:lstStyle/>
+          <a:p>
+            <a:pPr algn="ctr"/>
+            <a:endParaRPr lang="en-US"/>
+          </a:p>
+        </p:txBody>
+      </p:sp>
+      <p:sp>
+        <p:nvSpPr>
+          <p:cNvPr id="64" name="TextBox 63">
+            <a:extLst>
+              <a:ext uri="{FF2B5EF4-FFF2-40B4-BE49-F238E27FC236}">
+                <a16:creationId xmlns:a16="http://schemas.microsoft.com/office/drawing/2014/main" id="{78CA4776-B7D0-CBD4-A276-B73E02F408C9}"/>
+              </a:ext>
+            </a:extLst>
+          </p:cNvPr>
+          <p:cNvSpPr txBox="1"/>
+          <p:nvPr/>
+        </p:nvSpPr>
+        <p:spPr>
+          <a:xfrm>
+            <a:off x="2063334" y="1794996"/>
+            <a:ext cx="771943" cy="307777"/>
+          </a:xfrm>
+          <a:prstGeom prst="rect">
+            <a:avLst/>
+          </a:prstGeom>
+          <a:noFill/>
+        </p:spPr>
+        <p:txBody>
+          <a:bodyPr wrap="none" rtlCol="0">
+            <a:spAutoFit/>
+          </a:bodyPr>
+          <a:lstStyle/>
+          <a:p>
+            <a:r>
+              <a:rPr lang="en-US" sz="1400" dirty="0"/>
+              <a:t>EW_dst</a:t>
+            </a:r>
+          </a:p>
+        </p:txBody>
+      </p:sp>
+      <p:cxnSp>
+        <p:nvCxnSpPr>
+          <p:cNvPr id="65" name="Straight Connector 64">
+            <a:extLst>
+              <a:ext uri="{FF2B5EF4-FFF2-40B4-BE49-F238E27FC236}">
+                <a16:creationId xmlns:a16="http://schemas.microsoft.com/office/drawing/2014/main" id="{8C8DA906-6EBB-B1BF-5D8C-F8BFE1057BC4}"/>
+              </a:ext>
+            </a:extLst>
+          </p:cNvPr>
+          <p:cNvCxnSpPr>
+            <a:cxnSpLocks/>
+          </p:cNvCxnSpPr>
+          <p:nvPr/>
+        </p:nvCxnSpPr>
+        <p:spPr>
+          <a:xfrm>
+            <a:off x="2456448" y="1628239"/>
+            <a:ext cx="0" cy="121383"/>
+          </a:xfrm>
+          <a:prstGeom prst="line">
+            <a:avLst/>
+          </a:prstGeom>
+        </p:spPr>
+        <p:style>
+          <a:lnRef idx="2">
+            <a:schemeClr val="accent1"/>
+          </a:lnRef>
+          <a:fillRef idx="0">
+            <a:schemeClr val="accent1"/>
+          </a:fillRef>
+          <a:effectRef idx="1">
+            <a:schemeClr val="accent1"/>
+          </a:effectRef>
+          <a:fontRef idx="minor">
+            <a:schemeClr val="tx1"/>
+          </a:fontRef>
+        </p:style>
+      </p:cxnSp>
+      <p:grpSp>
+        <p:nvGrpSpPr>
+          <p:cNvPr id="69" name="Group 68">
+            <a:extLst>
+              <a:ext uri="{FF2B5EF4-FFF2-40B4-BE49-F238E27FC236}">
+                <a16:creationId xmlns:a16="http://schemas.microsoft.com/office/drawing/2014/main" id="{5C0F8DF7-CAA7-A7BC-9B6C-4D0DC51CD366}"/>
+              </a:ext>
+            </a:extLst>
+          </p:cNvPr>
+          <p:cNvGrpSpPr/>
+          <p:nvPr/>
+        </p:nvGrpSpPr>
+        <p:grpSpPr>
+          <a:xfrm>
+            <a:off x="2138487" y="417137"/>
+            <a:ext cx="620683" cy="376594"/>
+            <a:chOff x="954973" y="3240703"/>
+            <a:chExt cx="620683" cy="376594"/>
+          </a:xfrm>
+        </p:grpSpPr>
+        <p:sp>
+          <p:nvSpPr>
+            <p:cNvPr id="67" name="Rectangle 66">
+              <a:extLst>
+                <a:ext uri="{FF2B5EF4-FFF2-40B4-BE49-F238E27FC236}">
+                  <a16:creationId xmlns:a16="http://schemas.microsoft.com/office/drawing/2014/main" id="{B3EAC48A-AC2C-5C8C-250F-30836274E7A4}"/>
+                </a:ext>
+              </a:extLst>
+            </p:cNvPr>
+            <p:cNvSpPr/>
+            <p:nvPr/>
+          </p:nvSpPr>
+          <p:spPr>
+            <a:xfrm>
+              <a:off x="994841" y="3240703"/>
+              <a:ext cx="580815" cy="376594"/>
+            </a:xfrm>
+            <a:prstGeom prst="rect">
+              <a:avLst/>
+            </a:prstGeom>
+            <a:solidFill>
+              <a:schemeClr val="accent2">
+                <a:lumMod val="20000"/>
+                <a:lumOff val="80000"/>
+              </a:schemeClr>
+            </a:solidFill>
+          </p:spPr>
+          <p:style>
+            <a:lnRef idx="2">
+              <a:schemeClr val="accent1">
+                <a:shade val="15000"/>
+              </a:schemeClr>
+            </a:lnRef>
+            <a:fillRef idx="1">
+              <a:schemeClr val="accent1"/>
+            </a:fillRef>
+            <a:effectRef idx="0">
+              <a:schemeClr val="accent1"/>
+            </a:effectRef>
+            <a:fontRef idx="minor">
+              <a:schemeClr val="lt1"/>
+            </a:fontRef>
+          </p:style>
+          <p:txBody>
+            <a:bodyPr rtlCol="0" anchor="ctr"/>
+            <a:lstStyle/>
+            <a:p>
+              <a:pPr algn="ctr"/>
+              <a:endParaRPr lang="en-US"/>
+            </a:p>
+          </p:txBody>
+        </p:sp>
+        <p:sp>
+          <p:nvSpPr>
+            <p:cNvPr id="68" name="TextBox 67">
+              <a:extLst>
+                <a:ext uri="{FF2B5EF4-FFF2-40B4-BE49-F238E27FC236}">
+                  <a16:creationId xmlns:a16="http://schemas.microsoft.com/office/drawing/2014/main" id="{4A8EAD19-1640-F1E4-FC5C-4592C26C62E5}"/>
+                </a:ext>
+              </a:extLst>
+            </p:cNvPr>
+            <p:cNvSpPr txBox="1"/>
+            <p:nvPr/>
+          </p:nvSpPr>
+          <p:spPr>
+            <a:xfrm>
+              <a:off x="954973" y="3274381"/>
+              <a:ext cx="620683" cy="307777"/>
+            </a:xfrm>
+            <a:prstGeom prst="rect">
+              <a:avLst/>
+            </a:prstGeom>
+            <a:noFill/>
+          </p:spPr>
+          <p:txBody>
+            <a:bodyPr wrap="none" rtlCol="0">
+              <a:spAutoFit/>
+            </a:bodyPr>
+            <a:lstStyle/>
+            <a:p>
+              <a:r>
+                <a:rPr lang="en-US" sz="1400" dirty="0"/>
+                <a:t>client</a:t>
+              </a:r>
+            </a:p>
+          </p:txBody>
+        </p:sp>
+      </p:grpSp>
+      <p:cxnSp>
+        <p:nvCxnSpPr>
+          <p:cNvPr id="75" name="Straight Connector 74">
+            <a:extLst>
+              <a:ext uri="{FF2B5EF4-FFF2-40B4-BE49-F238E27FC236}">
+                <a16:creationId xmlns:a16="http://schemas.microsoft.com/office/drawing/2014/main" id="{F7713380-FD18-D602-1AD8-AF1DBA0EBAE7}"/>
+              </a:ext>
+            </a:extLst>
+          </p:cNvPr>
+          <p:cNvCxnSpPr>
+            <a:cxnSpLocks/>
+          </p:cNvCxnSpPr>
+          <p:nvPr/>
+        </p:nvCxnSpPr>
+        <p:spPr>
+          <a:xfrm>
+            <a:off x="2464068" y="797659"/>
+            <a:ext cx="0" cy="121383"/>
+          </a:xfrm>
+          <a:prstGeom prst="line">
+            <a:avLst/>
+          </a:prstGeom>
+        </p:spPr>
+        <p:style>
+          <a:lnRef idx="2">
+            <a:schemeClr val="accent1"/>
+          </a:lnRef>
+          <a:fillRef idx="0">
+            <a:schemeClr val="accent1"/>
+          </a:fillRef>
+          <a:effectRef idx="1">
+            <a:schemeClr val="accent1"/>
+          </a:effectRef>
+          <a:fontRef idx="minor">
+            <a:schemeClr val="tx1"/>
+          </a:fontRef>
+        </p:style>
+      </p:cxnSp>
+      <p:sp>
+        <p:nvSpPr>
+          <p:cNvPr id="76" name="Rectangle 75">
+            <a:extLst>
+              <a:ext uri="{FF2B5EF4-FFF2-40B4-BE49-F238E27FC236}">
+                <a16:creationId xmlns:a16="http://schemas.microsoft.com/office/drawing/2014/main" id="{8B48B7D2-433A-360F-5159-220C7360D36B}"/>
+              </a:ext>
+            </a:extLst>
+          </p:cNvPr>
+          <p:cNvSpPr/>
+          <p:nvPr/>
+        </p:nvSpPr>
+        <p:spPr>
+          <a:xfrm>
+            <a:off x="5023302" y="1116557"/>
+            <a:ext cx="737528" cy="376594"/>
+          </a:xfrm>
+          <a:prstGeom prst="rect">
+            <a:avLst/>
+          </a:prstGeom>
+          <a:solidFill>
+            <a:schemeClr val="accent2">
+              <a:lumMod val="20000"/>
+              <a:lumOff val="80000"/>
+            </a:schemeClr>
+          </a:solidFill>
+        </p:spPr>
+        <p:style>
+          <a:lnRef idx="2">
+            <a:schemeClr val="accent1">
+              <a:shade val="15000"/>
+            </a:schemeClr>
+          </a:lnRef>
+          <a:fillRef idx="1">
+            <a:schemeClr val="accent1"/>
+          </a:fillRef>
+          <a:effectRef idx="0">
+            <a:schemeClr val="accent1"/>
+          </a:effectRef>
+          <a:fontRef idx="minor">
+            <a:schemeClr val="lt1"/>
+          </a:fontRef>
+        </p:style>
+        <p:txBody>
+          <a:bodyPr rtlCol="0" anchor="ctr"/>
+          <a:lstStyle/>
+          <a:p>
+            <a:pPr algn="ctr"/>
+            <a:endParaRPr lang="en-US"/>
+          </a:p>
+        </p:txBody>
+      </p:sp>
+      <p:sp>
+        <p:nvSpPr>
+          <p:cNvPr id="77" name="TextBox 76">
+            <a:extLst>
+              <a:ext uri="{FF2B5EF4-FFF2-40B4-BE49-F238E27FC236}">
+                <a16:creationId xmlns:a16="http://schemas.microsoft.com/office/drawing/2014/main" id="{39B6F867-F662-EEE9-80DB-D3586FE323C2}"/>
+              </a:ext>
+            </a:extLst>
+          </p:cNvPr>
+          <p:cNvSpPr txBox="1"/>
+          <p:nvPr/>
+        </p:nvSpPr>
+        <p:spPr>
+          <a:xfrm>
+            <a:off x="4983434" y="1150235"/>
+            <a:ext cx="765722" cy="307777"/>
+          </a:xfrm>
+          <a:prstGeom prst="rect">
+            <a:avLst/>
+          </a:prstGeom>
+          <a:noFill/>
+        </p:spPr>
+        <p:txBody>
+          <a:bodyPr wrap="none" rtlCol="0">
+            <a:spAutoFit/>
+          </a:bodyPr>
+          <a:lstStyle/>
+          <a:p>
+            <a:r>
+              <a:rPr lang="en-US" sz="1400" dirty="0"/>
+              <a:t>EW_src</a:t>
+            </a:r>
+          </a:p>
+        </p:txBody>
+      </p:sp>
+      <p:sp>
+        <p:nvSpPr>
+          <p:cNvPr id="78" name="Rectangle 77">
+            <a:extLst>
+              <a:ext uri="{FF2B5EF4-FFF2-40B4-BE49-F238E27FC236}">
+                <a16:creationId xmlns:a16="http://schemas.microsoft.com/office/drawing/2014/main" id="{0B230463-8C3B-21F8-D6C4-63DE12BF3E60}"/>
+              </a:ext>
+            </a:extLst>
+          </p:cNvPr>
+          <p:cNvSpPr/>
+          <p:nvPr/>
+        </p:nvSpPr>
+        <p:spPr>
+          <a:xfrm>
+            <a:off x="4052029" y="951779"/>
+            <a:ext cx="823242" cy="694906"/>
+          </a:xfrm>
+          <a:prstGeom prst="rect">
+            <a:avLst/>
+          </a:prstGeom>
+          <a:solidFill>
+            <a:schemeClr val="accent4">
+              <a:lumMod val="20000"/>
+              <a:lumOff val="80000"/>
+            </a:schemeClr>
+          </a:solidFill>
+        </p:spPr>
+        <p:style>
+          <a:lnRef idx="2">
+            <a:schemeClr val="accent1">
+              <a:shade val="15000"/>
+            </a:schemeClr>
+          </a:lnRef>
+          <a:fillRef idx="1">
+            <a:schemeClr val="accent1"/>
+          </a:fillRef>
+          <a:effectRef idx="0">
+            <a:schemeClr val="accent1"/>
+          </a:effectRef>
+          <a:fontRef idx="minor">
+            <a:schemeClr val="lt1"/>
+          </a:fontRef>
+        </p:style>
+        <p:txBody>
+          <a:bodyPr rtlCol="0" anchor="ctr"/>
+          <a:lstStyle/>
+          <a:p>
+            <a:pPr algn="ctr"/>
+            <a:endParaRPr lang="en-US"/>
+          </a:p>
+        </p:txBody>
+      </p:sp>
+      <p:sp>
+        <p:nvSpPr>
+          <p:cNvPr id="79" name="TextBox 78">
+            <a:extLst>
+              <a:ext uri="{FF2B5EF4-FFF2-40B4-BE49-F238E27FC236}">
+                <a16:creationId xmlns:a16="http://schemas.microsoft.com/office/drawing/2014/main" id="{9AF049E7-D957-1B56-1B80-E36BA6B91116}"/>
+              </a:ext>
+            </a:extLst>
+          </p:cNvPr>
+          <p:cNvSpPr txBox="1"/>
+          <p:nvPr/>
+        </p:nvSpPr>
+        <p:spPr>
+          <a:xfrm>
+            <a:off x="4189683" y="658738"/>
+            <a:ext cx="524503" cy="1015663"/>
+          </a:xfrm>
+          <a:prstGeom prst="rect">
+            <a:avLst/>
+          </a:prstGeom>
+          <a:noFill/>
+        </p:spPr>
+        <p:txBody>
+          <a:bodyPr wrap="none" rtlCol="0">
+            <a:spAutoFit/>
+          </a:bodyPr>
+          <a:lstStyle/>
+          <a:p>
+            <a:r>
+              <a:rPr lang="en-US" sz="6000" dirty="0"/>
+              <a:t>x</a:t>
+            </a:r>
+          </a:p>
+        </p:txBody>
+      </p:sp>
+      <p:sp>
+        <p:nvSpPr>
+          <p:cNvPr id="80" name="TextBox 79">
+            <a:extLst>
+              <a:ext uri="{FF2B5EF4-FFF2-40B4-BE49-F238E27FC236}">
+                <a16:creationId xmlns:a16="http://schemas.microsoft.com/office/drawing/2014/main" id="{CBFD4DA8-3C2A-04CD-DB0D-42940867F4D1}"/>
+              </a:ext>
+            </a:extLst>
+          </p:cNvPr>
+          <p:cNvSpPr txBox="1"/>
+          <p:nvPr/>
+        </p:nvSpPr>
+        <p:spPr>
+          <a:xfrm>
+            <a:off x="4036464" y="1366624"/>
+            <a:ext cx="825291" cy="307777"/>
+          </a:xfrm>
+          <a:prstGeom prst="rect">
+            <a:avLst/>
+          </a:prstGeom>
+          <a:noFill/>
+        </p:spPr>
+        <p:txBody>
+          <a:bodyPr wrap="none" rtlCol="0">
+            <a:spAutoFit/>
+          </a:bodyPr>
+          <a:lstStyle/>
+          <a:p>
+            <a:r>
+              <a:rPr lang="en-US" sz="1400" dirty="0"/>
+              <a:t>hubEast</a:t>
+            </a:r>
+          </a:p>
+        </p:txBody>
+      </p:sp>
+      <p:cxnSp>
+        <p:nvCxnSpPr>
+          <p:cNvPr id="81" name="Straight Connector 80">
+            <a:extLst>
+              <a:ext uri="{FF2B5EF4-FFF2-40B4-BE49-F238E27FC236}">
+                <a16:creationId xmlns:a16="http://schemas.microsoft.com/office/drawing/2014/main" id="{1ECFBF18-ECFA-CCC2-5562-97EC43200FBA}"/>
+              </a:ext>
+            </a:extLst>
+          </p:cNvPr>
+          <p:cNvCxnSpPr>
+            <a:cxnSpLocks/>
+          </p:cNvCxnSpPr>
+          <p:nvPr/>
+        </p:nvCxnSpPr>
+        <p:spPr>
+          <a:xfrm flipH="1">
+            <a:off x="4886399" y="1302486"/>
+            <a:ext cx="127515" cy="0"/>
+          </a:xfrm>
+          <a:prstGeom prst="line">
+            <a:avLst/>
+          </a:prstGeom>
+        </p:spPr>
+        <p:style>
+          <a:lnRef idx="2">
+            <a:schemeClr val="accent1"/>
+          </a:lnRef>
+          <a:fillRef idx="0">
+            <a:schemeClr val="accent1"/>
+          </a:fillRef>
+          <a:effectRef idx="1">
+            <a:schemeClr val="accent1"/>
+          </a:effectRef>
+          <a:fontRef idx="minor">
+            <a:schemeClr val="tx1"/>
+          </a:fontRef>
+        </p:style>
+      </p:cxnSp>
+      <p:sp>
+        <p:nvSpPr>
+          <p:cNvPr id="82" name="Rectangle 81">
+            <a:extLst>
+              <a:ext uri="{FF2B5EF4-FFF2-40B4-BE49-F238E27FC236}">
+                <a16:creationId xmlns:a16="http://schemas.microsoft.com/office/drawing/2014/main" id="{D58288F5-20BD-47C2-313F-B2E5FE5B1477}"/>
+              </a:ext>
+            </a:extLst>
+          </p:cNvPr>
+          <p:cNvSpPr/>
+          <p:nvPr/>
+        </p:nvSpPr>
+        <p:spPr>
+          <a:xfrm>
+            <a:off x="4092891" y="1787970"/>
+            <a:ext cx="737528" cy="376594"/>
+          </a:xfrm>
+          <a:prstGeom prst="rect">
+            <a:avLst/>
+          </a:prstGeom>
+          <a:solidFill>
+            <a:schemeClr val="accent2">
+              <a:lumMod val="20000"/>
+              <a:lumOff val="80000"/>
+            </a:schemeClr>
+          </a:solidFill>
+        </p:spPr>
+        <p:style>
+          <a:lnRef idx="2">
+            <a:schemeClr val="accent1">
+              <a:shade val="15000"/>
+            </a:schemeClr>
+          </a:lnRef>
+          <a:fillRef idx="1">
+            <a:schemeClr val="accent1"/>
+          </a:fillRef>
+          <a:effectRef idx="0">
+            <a:schemeClr val="accent1"/>
+          </a:effectRef>
+          <a:fontRef idx="minor">
+            <a:schemeClr val="lt1"/>
+          </a:fontRef>
+        </p:style>
+        <p:txBody>
+          <a:bodyPr rtlCol="0" anchor="ctr"/>
+          <a:lstStyle/>
+          <a:p>
+            <a:pPr algn="ctr"/>
+            <a:endParaRPr lang="en-US"/>
+          </a:p>
+        </p:txBody>
+      </p:sp>
+      <p:sp>
+        <p:nvSpPr>
+          <p:cNvPr id="83" name="TextBox 82">
+            <a:extLst>
+              <a:ext uri="{FF2B5EF4-FFF2-40B4-BE49-F238E27FC236}">
+                <a16:creationId xmlns:a16="http://schemas.microsoft.com/office/drawing/2014/main" id="{B4B72059-B444-B892-6DCB-6D64347EB178}"/>
+              </a:ext>
+            </a:extLst>
+          </p:cNvPr>
+          <p:cNvSpPr txBox="1"/>
+          <p:nvPr/>
+        </p:nvSpPr>
+        <p:spPr>
+          <a:xfrm>
+            <a:off x="4053023" y="1821648"/>
+            <a:ext cx="771943" cy="307777"/>
+          </a:xfrm>
+          <a:prstGeom prst="rect">
+            <a:avLst/>
+          </a:prstGeom>
+          <a:noFill/>
+        </p:spPr>
+        <p:txBody>
+          <a:bodyPr wrap="none" rtlCol="0">
+            <a:spAutoFit/>
+          </a:bodyPr>
+          <a:lstStyle/>
+          <a:p>
+            <a:r>
+              <a:rPr lang="en-US" sz="1400" dirty="0"/>
+              <a:t>WE_dst</a:t>
+            </a:r>
+          </a:p>
+        </p:txBody>
+      </p:sp>
+      <p:cxnSp>
+        <p:nvCxnSpPr>
+          <p:cNvPr id="84" name="Straight Connector 83">
+            <a:extLst>
+              <a:ext uri="{FF2B5EF4-FFF2-40B4-BE49-F238E27FC236}">
+                <a16:creationId xmlns:a16="http://schemas.microsoft.com/office/drawing/2014/main" id="{35062C4C-477B-956B-8392-DAC950CFB07B}"/>
+              </a:ext>
+            </a:extLst>
+          </p:cNvPr>
+          <p:cNvCxnSpPr>
+            <a:cxnSpLocks/>
+          </p:cNvCxnSpPr>
+          <p:nvPr/>
+        </p:nvCxnSpPr>
+        <p:spPr>
+          <a:xfrm>
+            <a:off x="4446137" y="1654891"/>
+            <a:ext cx="0" cy="121383"/>
+          </a:xfrm>
+          <a:prstGeom prst="line">
+            <a:avLst/>
+          </a:prstGeom>
+        </p:spPr>
+        <p:style>
+          <a:lnRef idx="2">
+            <a:schemeClr val="accent1"/>
+          </a:lnRef>
+          <a:fillRef idx="0">
+            <a:schemeClr val="accent1"/>
+          </a:fillRef>
+          <a:effectRef idx="1">
+            <a:schemeClr val="accent1"/>
+          </a:effectRef>
+          <a:fontRef idx="minor">
+            <a:schemeClr val="tx1"/>
+          </a:fontRef>
+        </p:style>
+      </p:cxnSp>
+      <p:grpSp>
+        <p:nvGrpSpPr>
+          <p:cNvPr id="85" name="Group 84">
+            <a:extLst>
+              <a:ext uri="{FF2B5EF4-FFF2-40B4-BE49-F238E27FC236}">
+                <a16:creationId xmlns:a16="http://schemas.microsoft.com/office/drawing/2014/main" id="{70202A54-CFF0-3799-F733-D8863A4E0828}"/>
+              </a:ext>
+            </a:extLst>
+          </p:cNvPr>
+          <p:cNvGrpSpPr/>
+          <p:nvPr/>
+        </p:nvGrpSpPr>
+        <p:grpSpPr>
+          <a:xfrm>
+            <a:off x="4128176" y="443789"/>
+            <a:ext cx="661720" cy="376594"/>
+            <a:chOff x="954973" y="3240703"/>
+            <a:chExt cx="661720" cy="376594"/>
+          </a:xfrm>
+        </p:grpSpPr>
+        <p:sp>
+          <p:nvSpPr>
+            <p:cNvPr id="86" name="Rectangle 85">
+              <a:extLst>
+                <a:ext uri="{FF2B5EF4-FFF2-40B4-BE49-F238E27FC236}">
+                  <a16:creationId xmlns:a16="http://schemas.microsoft.com/office/drawing/2014/main" id="{1C5C1C3F-6BA6-F934-A690-9182590D27DF}"/>
+                </a:ext>
+              </a:extLst>
+            </p:cNvPr>
+            <p:cNvSpPr/>
+            <p:nvPr/>
+          </p:nvSpPr>
+          <p:spPr>
+            <a:xfrm>
+              <a:off x="994841" y="3240703"/>
+              <a:ext cx="580815" cy="376594"/>
+            </a:xfrm>
+            <a:prstGeom prst="rect">
+              <a:avLst/>
+            </a:prstGeom>
+            <a:solidFill>
+              <a:schemeClr val="accent2">
+                <a:lumMod val="20000"/>
+                <a:lumOff val="80000"/>
+              </a:schemeClr>
+            </a:solidFill>
+          </p:spPr>
+          <p:style>
+            <a:lnRef idx="2">
+              <a:schemeClr val="accent1">
+                <a:shade val="15000"/>
+              </a:schemeClr>
+            </a:lnRef>
+            <a:fillRef idx="1">
+              <a:schemeClr val="accent1"/>
+            </a:fillRef>
+            <a:effectRef idx="0">
+              <a:schemeClr val="accent1"/>
+            </a:effectRef>
+            <a:fontRef idx="minor">
+              <a:schemeClr val="lt1"/>
+            </a:fontRef>
+          </p:style>
+          <p:txBody>
+            <a:bodyPr rtlCol="0" anchor="ctr"/>
+            <a:lstStyle/>
+            <a:p>
+              <a:pPr algn="ctr"/>
+              <a:endParaRPr lang="en-US"/>
+            </a:p>
+          </p:txBody>
+        </p:sp>
+        <p:sp>
+          <p:nvSpPr>
+            <p:cNvPr id="87" name="TextBox 86">
+              <a:extLst>
+                <a:ext uri="{FF2B5EF4-FFF2-40B4-BE49-F238E27FC236}">
+                  <a16:creationId xmlns:a16="http://schemas.microsoft.com/office/drawing/2014/main" id="{59E75926-1807-38BA-CF50-E6896A6F48E6}"/>
+                </a:ext>
+              </a:extLst>
+            </p:cNvPr>
+            <p:cNvSpPr txBox="1"/>
+            <p:nvPr/>
+          </p:nvSpPr>
+          <p:spPr>
+            <a:xfrm>
+              <a:off x="954973" y="3274381"/>
+              <a:ext cx="661720" cy="307777"/>
+            </a:xfrm>
+            <a:prstGeom prst="rect">
+              <a:avLst/>
+            </a:prstGeom>
+            <a:noFill/>
+          </p:spPr>
+          <p:txBody>
+            <a:bodyPr wrap="none" rtlCol="0">
+              <a:spAutoFit/>
+            </a:bodyPr>
+            <a:lstStyle/>
+            <a:p>
+              <a:r>
+                <a:rPr lang="en-US" sz="1400" dirty="0"/>
+                <a:t>server</a:t>
+              </a:r>
+            </a:p>
+          </p:txBody>
+        </p:sp>
+      </p:grpSp>
+      <p:cxnSp>
+        <p:nvCxnSpPr>
+          <p:cNvPr id="88" name="Straight Connector 87">
+            <a:extLst>
+              <a:ext uri="{FF2B5EF4-FFF2-40B4-BE49-F238E27FC236}">
+                <a16:creationId xmlns:a16="http://schemas.microsoft.com/office/drawing/2014/main" id="{AECDEC57-1602-B49C-9A53-0F517F52E390}"/>
+              </a:ext>
+            </a:extLst>
+          </p:cNvPr>
+          <p:cNvCxnSpPr>
+            <a:cxnSpLocks/>
+          </p:cNvCxnSpPr>
+          <p:nvPr/>
+        </p:nvCxnSpPr>
+        <p:spPr>
+          <a:xfrm>
+            <a:off x="4453757" y="824311"/>
+            <a:ext cx="0" cy="121383"/>
+          </a:xfrm>
+          <a:prstGeom prst="line">
+            <a:avLst/>
+          </a:prstGeom>
+        </p:spPr>
+        <p:style>
+          <a:lnRef idx="2">
+            <a:schemeClr val="accent1"/>
+          </a:lnRef>
+          <a:fillRef idx="0">
+            <a:schemeClr val="accent1"/>
+          </a:fillRef>
+          <a:effectRef idx="1">
+            <a:schemeClr val="accent1"/>
+          </a:effectRef>
+          <a:fontRef idx="minor">
+            <a:schemeClr val="tx1"/>
+          </a:fontRef>
+        </p:style>
+      </p:cxnSp>
+      <p:sp>
+        <p:nvSpPr>
+          <p:cNvPr id="91" name="Rounded Rectangle 90">
+            <a:extLst>
+              <a:ext uri="{FF2B5EF4-FFF2-40B4-BE49-F238E27FC236}">
+                <a16:creationId xmlns:a16="http://schemas.microsoft.com/office/drawing/2014/main" id="{CB580E7C-C0F5-967F-2D65-E20DBECCB81C}"/>
+              </a:ext>
+            </a:extLst>
+          </p:cNvPr>
+          <p:cNvSpPr/>
+          <p:nvPr/>
+        </p:nvSpPr>
+        <p:spPr>
+          <a:xfrm>
+            <a:off x="960120" y="152400"/>
+            <a:ext cx="2523418" cy="2217420"/>
+          </a:xfrm>
+          <a:prstGeom prst="roundRect">
+            <a:avLst/>
+          </a:prstGeom>
+          <a:noFill/>
+          <a:ln>
+            <a:solidFill>
+              <a:schemeClr val="tx1"/>
+            </a:solidFill>
+            <a:prstDash val="dash"/>
+          </a:ln>
+        </p:spPr>
+        <p:style>
+          <a:lnRef idx="2">
+            <a:schemeClr val="accent1">
+              <a:shade val="15000"/>
+            </a:schemeClr>
+          </a:lnRef>
+          <a:fillRef idx="1">
+            <a:schemeClr val="accent1"/>
+          </a:fillRef>
+          <a:effectRef idx="0">
+            <a:schemeClr val="accent1"/>
+          </a:effectRef>
+          <a:fontRef idx="minor">
+            <a:schemeClr val="lt1"/>
+          </a:fontRef>
+        </p:style>
+        <p:txBody>
+          <a:bodyPr rtlCol="0" anchor="ctr"/>
+          <a:lstStyle/>
+          <a:p>
+            <a:pPr algn="ctr"/>
+            <a:endParaRPr lang="en-US"/>
+          </a:p>
+        </p:txBody>
+      </p:sp>
+      <p:sp>
+        <p:nvSpPr>
+          <p:cNvPr id="92" name="Rounded Rectangle 91">
+            <a:extLst>
+              <a:ext uri="{FF2B5EF4-FFF2-40B4-BE49-F238E27FC236}">
+                <a16:creationId xmlns:a16="http://schemas.microsoft.com/office/drawing/2014/main" id="{FFC70642-6290-63A5-06E6-9F9EA1F18B13}"/>
+              </a:ext>
+            </a:extLst>
+          </p:cNvPr>
+          <p:cNvSpPr/>
+          <p:nvPr/>
+        </p:nvSpPr>
+        <p:spPr>
+          <a:xfrm>
+            <a:off x="3505075" y="152400"/>
+            <a:ext cx="2523418" cy="2217420"/>
+          </a:xfrm>
+          <a:prstGeom prst="roundRect">
+            <a:avLst/>
+          </a:prstGeom>
+          <a:noFill/>
+          <a:ln>
+            <a:solidFill>
+              <a:schemeClr val="tx1"/>
+            </a:solidFill>
+            <a:prstDash val="dash"/>
+          </a:ln>
+        </p:spPr>
+        <p:style>
+          <a:lnRef idx="2">
+            <a:schemeClr val="accent1">
+              <a:shade val="15000"/>
+            </a:schemeClr>
+          </a:lnRef>
+          <a:fillRef idx="1">
+            <a:schemeClr val="accent1"/>
+          </a:fillRef>
+          <a:effectRef idx="0">
+            <a:schemeClr val="accent1"/>
+          </a:effectRef>
+          <a:fontRef idx="minor">
+            <a:schemeClr val="lt1"/>
+          </a:fontRef>
+        </p:style>
+        <p:txBody>
+          <a:bodyPr rtlCol="0" anchor="ctr"/>
+          <a:lstStyle/>
+          <a:p>
+            <a:pPr algn="ctr"/>
+            <a:endParaRPr lang="en-US"/>
+          </a:p>
+        </p:txBody>
+      </p:sp>
+      <p:sp>
+        <p:nvSpPr>
+          <p:cNvPr id="93" name="TextBox 92">
+            <a:extLst>
+              <a:ext uri="{FF2B5EF4-FFF2-40B4-BE49-F238E27FC236}">
+                <a16:creationId xmlns:a16="http://schemas.microsoft.com/office/drawing/2014/main" id="{A14F43B2-24E8-2FC5-3AD7-E7614DA1FA26}"/>
+              </a:ext>
+            </a:extLst>
+          </p:cNvPr>
+          <p:cNvSpPr txBox="1"/>
+          <p:nvPr/>
+        </p:nvSpPr>
+        <p:spPr>
+          <a:xfrm>
+            <a:off x="967098" y="1746795"/>
+            <a:ext cx="1015919" cy="369332"/>
+          </a:xfrm>
+          <a:prstGeom prst="rect">
+            <a:avLst/>
+          </a:prstGeom>
+          <a:noFill/>
+        </p:spPr>
+        <p:txBody>
+          <a:bodyPr wrap="none" rtlCol="0">
+            <a:spAutoFit/>
+          </a:bodyPr>
+          <a:lstStyle/>
+          <a:p>
+            <a:r>
+              <a:rPr lang="en-US"/>
+              <a:t>netWest</a:t>
+            </a:r>
+          </a:p>
+        </p:txBody>
+      </p:sp>
+      <p:sp>
+        <p:nvSpPr>
+          <p:cNvPr id="94" name="TextBox 93">
+            <a:extLst>
+              <a:ext uri="{FF2B5EF4-FFF2-40B4-BE49-F238E27FC236}">
+                <a16:creationId xmlns:a16="http://schemas.microsoft.com/office/drawing/2014/main" id="{8028AF93-F420-B749-E345-1DF722D2B525}"/>
+              </a:ext>
+            </a:extLst>
+          </p:cNvPr>
+          <p:cNvSpPr txBox="1"/>
+          <p:nvPr/>
+        </p:nvSpPr>
+        <p:spPr>
+          <a:xfrm>
+            <a:off x="5013914" y="1787970"/>
+            <a:ext cx="946926" cy="369332"/>
+          </a:xfrm>
+          <a:prstGeom prst="rect">
+            <a:avLst/>
+          </a:prstGeom>
+          <a:noFill/>
+        </p:spPr>
+        <p:txBody>
+          <a:bodyPr wrap="none" rtlCol="0">
+            <a:spAutoFit/>
+          </a:bodyPr>
+          <a:lstStyle/>
+          <a:p>
+            <a:r>
+              <a:rPr lang="en-US"/>
+              <a:t>netEast</a:t>
+            </a:r>
+          </a:p>
+        </p:txBody>
+      </p:sp>
+      <p:cxnSp>
+        <p:nvCxnSpPr>
+          <p:cNvPr id="3" name="Straight Connector 2">
+            <a:extLst>
+              <a:ext uri="{FF2B5EF4-FFF2-40B4-BE49-F238E27FC236}">
+                <a16:creationId xmlns:a16="http://schemas.microsoft.com/office/drawing/2014/main" id="{B5D2FE7A-6C2F-B055-E1BC-F9973B921AAB}"/>
+              </a:ext>
+            </a:extLst>
+          </p:cNvPr>
+          <p:cNvCxnSpPr>
+            <a:cxnSpLocks/>
+          </p:cNvCxnSpPr>
+          <p:nvPr/>
+        </p:nvCxnSpPr>
+        <p:spPr>
+          <a:xfrm>
+            <a:off x="2538744" y="687625"/>
+            <a:ext cx="0" cy="528308"/>
+          </a:xfrm>
+          <a:prstGeom prst="line">
+            <a:avLst/>
+          </a:prstGeom>
+          <a:ln w="38100">
+            <a:solidFill>
+              <a:srgbClr val="FF0000"/>
+            </a:solidFill>
+          </a:ln>
+        </p:spPr>
+        <p:style>
+          <a:lnRef idx="2">
+            <a:schemeClr val="accent1"/>
+          </a:lnRef>
+          <a:fillRef idx="0">
+            <a:schemeClr val="accent1"/>
+          </a:fillRef>
+          <a:effectRef idx="1">
+            <a:schemeClr val="accent1"/>
+          </a:effectRef>
+          <a:fontRef idx="minor">
+            <a:schemeClr val="tx1"/>
+          </a:fontRef>
+        </p:style>
+      </p:cxnSp>
+      <p:cxnSp>
+        <p:nvCxnSpPr>
+          <p:cNvPr id="4" name="Straight Connector 3">
+            <a:extLst>
+              <a:ext uri="{FF2B5EF4-FFF2-40B4-BE49-F238E27FC236}">
+                <a16:creationId xmlns:a16="http://schemas.microsoft.com/office/drawing/2014/main" id="{D6BF75B3-42E1-AE55-9124-5D379B322325}"/>
+              </a:ext>
+            </a:extLst>
+          </p:cNvPr>
+          <p:cNvCxnSpPr>
+            <a:cxnSpLocks/>
+          </p:cNvCxnSpPr>
+          <p:nvPr/>
+        </p:nvCxnSpPr>
+        <p:spPr>
+          <a:xfrm flipH="1" flipV="1">
+            <a:off x="2538744" y="1215933"/>
+            <a:ext cx="1915013" cy="9145"/>
+          </a:xfrm>
+          <a:prstGeom prst="line">
+            <a:avLst/>
+          </a:prstGeom>
+          <a:ln w="38100">
+            <a:solidFill>
+              <a:srgbClr val="FF0000"/>
+            </a:solidFill>
+          </a:ln>
+        </p:spPr>
+        <p:style>
+          <a:lnRef idx="2">
+            <a:schemeClr val="accent1"/>
+          </a:lnRef>
+          <a:fillRef idx="0">
+            <a:schemeClr val="accent1"/>
+          </a:fillRef>
+          <a:effectRef idx="1">
+            <a:schemeClr val="accent1"/>
+          </a:effectRef>
+          <a:fontRef idx="minor">
+            <a:schemeClr val="tx1"/>
+          </a:fontRef>
+        </p:style>
+      </p:cxnSp>
+      <p:cxnSp>
+        <p:nvCxnSpPr>
+          <p:cNvPr id="8" name="Straight Connector 7">
+            <a:extLst>
+              <a:ext uri="{FF2B5EF4-FFF2-40B4-BE49-F238E27FC236}">
+                <a16:creationId xmlns:a16="http://schemas.microsoft.com/office/drawing/2014/main" id="{3363ACD9-FDC3-15CF-DF33-82EE90A7C448}"/>
+              </a:ext>
+            </a:extLst>
+          </p:cNvPr>
+          <p:cNvCxnSpPr>
+            <a:cxnSpLocks/>
+          </p:cNvCxnSpPr>
+          <p:nvPr/>
+        </p:nvCxnSpPr>
+        <p:spPr>
+          <a:xfrm>
+            <a:off x="4446137" y="687625"/>
+            <a:ext cx="0" cy="528308"/>
+          </a:xfrm>
+          <a:prstGeom prst="line">
+            <a:avLst/>
+          </a:prstGeom>
+          <a:ln w="38100">
+            <a:solidFill>
+              <a:srgbClr val="FF0000"/>
+            </a:solidFill>
+            <a:headEnd type="triangle"/>
+            <a:tailEnd type="none"/>
+          </a:ln>
+        </p:spPr>
+        <p:style>
+          <a:lnRef idx="2">
+            <a:schemeClr val="accent1"/>
+          </a:lnRef>
+          <a:fillRef idx="0">
+            <a:schemeClr val="accent1"/>
+          </a:fillRef>
+          <a:effectRef idx="1">
+            <a:schemeClr val="accent1"/>
+          </a:effectRef>
+          <a:fontRef idx="minor">
+            <a:schemeClr val="tx1"/>
+          </a:fontRef>
+        </p:style>
+      </p:cxnSp>
+      <p:cxnSp>
+        <p:nvCxnSpPr>
+          <p:cNvPr id="9" name="Straight Connector 8">
+            <a:extLst>
+              <a:ext uri="{FF2B5EF4-FFF2-40B4-BE49-F238E27FC236}">
+                <a16:creationId xmlns:a16="http://schemas.microsoft.com/office/drawing/2014/main" id="{604BDA42-1940-4D1B-B853-079F3637985F}"/>
+              </a:ext>
+            </a:extLst>
+          </p:cNvPr>
+          <p:cNvCxnSpPr>
+            <a:cxnSpLocks/>
+            <a:stCxn id="80" idx="0"/>
+          </p:cNvCxnSpPr>
+          <p:nvPr/>
+        </p:nvCxnSpPr>
+        <p:spPr>
+          <a:xfrm flipH="1" flipV="1">
+            <a:off x="1817157" y="1363357"/>
+            <a:ext cx="2631953" cy="3267"/>
+          </a:xfrm>
+          <a:prstGeom prst="line">
+            <a:avLst/>
+          </a:prstGeom>
+          <a:ln w="38100">
+            <a:solidFill>
+              <a:schemeClr val="accent3">
+                <a:lumMod val="60000"/>
+                <a:lumOff val="40000"/>
+              </a:schemeClr>
+            </a:solidFill>
+          </a:ln>
+        </p:spPr>
+        <p:style>
+          <a:lnRef idx="2">
+            <a:schemeClr val="accent1"/>
+          </a:lnRef>
+          <a:fillRef idx="0">
+            <a:schemeClr val="accent1"/>
+          </a:fillRef>
+          <a:effectRef idx="1">
+            <a:schemeClr val="accent1"/>
+          </a:effectRef>
+          <a:fontRef idx="minor">
+            <a:schemeClr val="tx1"/>
+          </a:fontRef>
+        </p:style>
+      </p:cxnSp>
+      <p:cxnSp>
+        <p:nvCxnSpPr>
+          <p:cNvPr id="21" name="Straight Connector 20">
+            <a:extLst>
+              <a:ext uri="{FF2B5EF4-FFF2-40B4-BE49-F238E27FC236}">
+                <a16:creationId xmlns:a16="http://schemas.microsoft.com/office/drawing/2014/main" id="{D3B82D93-3070-0FEE-3BB4-170A2DA4DA6A}"/>
+              </a:ext>
+            </a:extLst>
+          </p:cNvPr>
+          <p:cNvCxnSpPr>
+            <a:cxnSpLocks/>
+          </p:cNvCxnSpPr>
+          <p:nvPr/>
+        </p:nvCxnSpPr>
+        <p:spPr>
+          <a:xfrm flipV="1">
+            <a:off x="4406513" y="1379348"/>
+            <a:ext cx="0" cy="528308"/>
+          </a:xfrm>
+          <a:prstGeom prst="line">
+            <a:avLst/>
+          </a:prstGeom>
+          <a:ln w="38100">
+            <a:solidFill>
+              <a:schemeClr val="accent3">
+                <a:lumMod val="60000"/>
+                <a:lumOff val="40000"/>
+              </a:schemeClr>
+            </a:solidFill>
+            <a:headEnd type="triangle"/>
+            <a:tailEnd type="none"/>
+          </a:ln>
+        </p:spPr>
+        <p:style>
+          <a:lnRef idx="2">
+            <a:schemeClr val="accent1"/>
+          </a:lnRef>
+          <a:fillRef idx="0">
+            <a:schemeClr val="accent1"/>
+          </a:fillRef>
+          <a:effectRef idx="1">
+            <a:schemeClr val="accent1"/>
+          </a:effectRef>
+          <a:fontRef idx="minor">
+            <a:schemeClr val="tx1"/>
+          </a:fontRef>
+        </p:style>
+      </p:cxnSp>
+    </p:spTree>
+    <p:extLst>
+      <p:ext uri="{BB962C8B-B14F-4D97-AF65-F5344CB8AC3E}">
+        <p14:creationId xmlns:p14="http://schemas.microsoft.com/office/powerpoint/2010/main" val="2475031369"/>
+      </p:ext>
+    </p:extLst>
+  </p:cSld>
+  <p:clrMapOvr>
+    <a:masterClrMapping/>
+  </p:clrMapOvr>
+</p:sld>
+</file>
+
 <file path=ppt/slides/slide2.xml><?xml version="1.0" encoding="utf-8"?>
 <p:sld xmlns:a="http://schemas.openxmlformats.org/drawingml/2006/main" xmlns:r="http://schemas.openxmlformats.org/officeDocument/2006/relationships" xmlns:p="http://schemas.openxmlformats.org/presentationml/2006/main">
   <p:cSld>

</xml_diff>